<commit_message>
Embed the UAE statistics slides in decks 1–5
Each of the five audience decks now carries a tailored block of the
statistics slides (surveys, registries, settlement time, business
impact, sources) reused from deck6 through stats_common.js, in all three
languages. Side-panel headings size adaptively for long Russian text.

Co-Authored-By: Claude Fable 5.1 <noreply@anthropic.com>
Claude-Session: https://claude.ai/code/session_016iqXZoJfFPSeJnjhoiAqom
</commit_message>
<xml_diff>
--- a/presentations/06_UAE_Wills_Inheritance_Statistics_AR.pptx
+++ b/presentations/06_UAE_Wills_Inheritance_Statistics_AR.pptx
@@ -132,20 +132,20 @@
   <p:extLst>
     <p:ext uri="{521415D9-36F7-43E2-AB2F-B90AF26B5E84}">
       <p14:sectionLst xmlns:p14="http://schemas.microsoft.com/office/powerpoint/2010/main">
-        <p14:section name="المقدمة" id="{6a079376-c191-efcc-ef75-2c7e0673c840}">
+        <p14:section name="المقدمة" id="{0f2d3203-9520-fe54-ab0e-23532466f29f}">
           <p14:sldIdLst>
             <p14:sldId id="256"/>
             <p14:sldId id="257"/>
             <p14:sldId id="258"/>
           </p14:sldIdLst>
         </p14:section>
-        <p14:section name="السياق" id="{24b338fb-4d69-9ae1-1c40-d255101db0da}">
+        <p14:section name="السياق" id="{be51551e-44b3-9789-ac64-03d08aa66b43}">
           <p14:sldIdLst>
             <p14:sldId id="259"/>
             <p14:sldId id="260"/>
           </p14:sldIdLst>
         </p14:section>
-        <p14:section name="من يملك وصية" id="{696766bd-082f-324e-b2dc-885aada55b5c}">
+        <p14:section name="من يملك وصية" id="{7dac94ac-b048-dff0-245b-0cac1d1ec6b4}">
           <p14:sldIdLst>
             <p14:sldId id="261"/>
             <p14:sldId id="262"/>
@@ -156,7 +156,7 @@
             <p14:sldId id="267"/>
           </p14:sldIdLst>
         </p14:section>
-        <p14:section name="السرعة والمشاكل" id="{06a136ed-f9c0-55f4-5e3a-dad5d336e8e3}">
+        <p14:section name="السرعة والمشاكل" id="{b03f6c4d-1ad0-0a1b-af3c-14f63a4c85be}">
           <p14:sldIdLst>
             <p14:sldId id="268"/>
             <p14:sldId id="269"/>
@@ -165,7 +165,7 @@
             <p14:sldId id="272"/>
           </p14:sldIdLst>
         </p14:section>
-        <p14:section name="الشركات" id="{1a31948f-44a7-b210-9385-462d64d3ea53}">
+        <p14:section name="الشركات" id="{018033b0-1d88-ed1f-93e0-4ed9a3a26225}">
           <p14:sldIdLst>
             <p14:sldId id="273"/>
             <p14:sldId id="274"/>
@@ -173,7 +173,7 @@
             <p14:sldId id="276"/>
           </p14:sldIdLst>
         </p14:section>
-        <p14:section name="حدود البيانات" id="{1c3d6d0e-68b2-22af-81d3-bf45310183f6}">
+        <p14:section name="حدود البيانات" id="{61465e12-daaa-3526-3437-af68d4ca1561}">
           <p14:sldIdLst>
             <p14:sldId id="277"/>
             <p14:sldId id="278"/>

</xml_diff>